<commit_message>
Add review camera to scanner physical offset model
</commit_message>
<xml_diff>
--- a/downloadable/MOF_COORDINATE_TEAM_LEADER_REPORT_20260717.pptx
+++ b/downloadable/MOF_COORDINATE_TEAM_LEADER_REPORT_20260717.pptx
@@ -455,7 +455,7 @@
                   <a:srgbClr val="F8FAFC"/>
                 </a:solidFill>
               </a:rPr>
-              <a:t>9. Step 5 - Scanner 내부 명령 Gx/Gy를 만든다</a:t>
+              <a:t>9. Step 5 - 물리 Offset을 적용해 Gx/Gy를 만든다</a:t>
             </a:r>
           </a:p>
         </p:txBody>
@@ -493,37 +493,37 @@
                   <a:srgbClr val="E5E7EB"/>
                 </a:solidFill>
               </a:rPr>
-              <a:t>Stage 좌표와 Scanner 좌표 차이</a:t>
-            </a:r>
-          </a:p>
-          <a:p>
-            <a:r>
-              <a:rPr lang="ko-KR" sz="1600">
-                <a:solidFill>
-                  <a:srgbClr val="E5E7EB"/>
-                </a:solidFill>
-              </a:rPr>
-              <a:t>Stage 좌표는 장비 전체 주소입니다.</a:t>
-            </a:r>
-          </a:p>
-          <a:p>
-            <a:r>
-              <a:rPr lang="ko-KR" sz="1600">
-                <a:solidFill>
-                  <a:srgbClr val="E5E7EB"/>
-                </a:solidFill>
-              </a:rPr>
-              <a:t>Scanner는 자기 중심을 기준으로 상대 위치를 봅니다.</a:t>
-            </a:r>
-          </a:p>
-          <a:p>
-            <a:r>
-              <a:rPr lang="ko-KR" sz="1600">
-                <a:solidFill>
-                  <a:srgbClr val="E5E7EB"/>
-                </a:solidFill>
-              </a:rPr>
-              <a:t>따라서 Target에서 Scanner 중심을 빼서 상대 좌표를 만듭니다.</a:t>
+              <a:t>Review Camera와 Scanner 중심의 물리적 차이</a:t>
+            </a:r>
+          </a:p>
+          <a:p>
+            <a:r>
+              <a:rPr lang="ko-KR" sz="1600">
+                <a:solidFill>
+                  <a:srgbClr val="E5E7EB"/>
+                </a:solidFill>
+              </a:rPr>
+              <a:t>Review Camera 중심과 Scanner 가공 중심은 물리적으로 떨어져 있습니다.</a:t>
+            </a:r>
+          </a:p>
+          <a:p>
+            <a:r>
+              <a:rPr lang="ko-KR" sz="1600">
+                <a:solidFill>
+                  <a:srgbClr val="E5E7EB"/>
+                </a:solidFill>
+              </a:rPr>
+              <a:t>Camera→Scanner 고정 물리 Offset을 적용해야 같은 가공점을 Scanner 기준으로 옮길 수 있습니다.</a:t>
+            </a:r>
+          </a:p>
+          <a:p>
+            <a:r>
+              <a:rPr lang="ko-KR" sz="1600">
+                <a:solidFill>
+                  <a:srgbClr val="E5E7EB"/>
+                </a:solidFill>
+              </a:rPr>
+              <a:t>먼저 Camera 기준 상대좌표를 만들고 Head별 Physical Offset을 뺍니다.</a:t>
             </a:r>
           </a:p>
         </p:txBody>
@@ -571,17 +571,17 @@
                   <a:srgbClr val="E5E7EB"/>
                 </a:solidFill>
               </a:rPr>
-              <a:t>Dx = ProcessStageX - ScannerCenterX</a:t>
-            </a:r>
-          </a:p>
-          <a:p>
-            <a:r>
-              <a:rPr lang="ko-KR" sz="1600">
-                <a:solidFill>
-                  <a:srgbClr val="E5E7EB"/>
-                </a:solidFill>
-              </a:rPr>
-              <a:t>Dy = ProcessStageY - ScannerCenterY</a:t>
+              <a:t>CameraRelative = ProcessStage - ReviewCenter</a:t>
+            </a:r>
+          </a:p>
+          <a:p>
+            <a:r>
+              <a:rPr lang="ko-KR" sz="1600">
+                <a:solidFill>
+                  <a:srgbClr val="E5E7EB"/>
+                </a:solidFill>
+              </a:rPr>
+              <a:t>ScannerRelative = CameraRelative - CameraToScannerPhysicalOffset</a:t>
             </a:r>
           </a:p>
           <a:p>
@@ -1013,7 +1013,7 @@
                   <a:srgbClr val="F8FAFC"/>
                 </a:solidFill>
               </a:rPr>
-              <a:t>11. Step 7 - Review Offset으로 다음 가공을 보정한다</a:t>
+              <a:t>11. Step 7 - Dynamic Review Correction으로 다음 가공을 보정한다</a:t>
             </a:r>
           </a:p>
         </p:txBody>
@@ -1081,7 +1081,7 @@
                   <a:srgbClr val="E5E7EB"/>
                 </a:solidFill>
               </a:rPr>
-              <a:t>이 오차를 다음 가공 좌표에 보정값으로 넣습니다.</a:t>
+              <a:t>이 오차는 Dynamic Review Correction으로 다음 가공에 반영하며, 장비 치수인 Physical Offset과 분리합니다.</a:t>
             </a:r>
           </a:p>
         </p:txBody>
@@ -1991,7 +1991,7 @@
                   <a:srgbClr val="E5E7EB"/>
                 </a:solidFill>
               </a:rPr>
-              <a:t>3) Review Offset/DOE 구조가 들어갈 수 있도록 Base 구조를 잡아두었습니다.</a:t>
+              <a:t>3) Camera→Scanner Physical Offset과 Dynamic Review Correction을 분리했습니다.</a:t>
             </a:r>
           </a:p>
           <a:p>
@@ -2401,7 +2401,7 @@
                   <a:srgbClr val="E5E7EB"/>
                 </a:solidFill>
               </a:rPr>
-              <a:t>• Head별 실제 Center 보정값</a:t>
+              <a:t>• Review Camera→H1 Physical Offset 실측값</a:t>
             </a:r>
           </a:p>
           <a:p>
@@ -3133,7 +3133,7 @@
                   <a:srgbClr val="E5E7EB"/>
                 </a:solidFill>
               </a:rPr>
-              <a:t>일부러 더하거나 빼는 보정값입니다.</a:t>
+              <a:t>Physical Offset은 Camera와 Scanner의 고정거리이고, Dynamic Correction은 가공 후 오차 보정값입니다.</a:t>
             </a:r>
           </a:p>
           <a:p>
@@ -3751,7 +3751,7 @@
                   <a:srgbClr val="E5E7EB"/>
                 </a:solidFill>
               </a:rPr>
-              <a:t>5) Scanner는 고정되어 있고, 기판이 Y 방향으로 지나간다고 설명합니다.</a:t>
+              <a:t>5) Camera와 Scanner 사이의 고정 물리 Offset을 먼저 설명합니다.</a:t>
             </a:r>
           </a:p>
           <a:p>
@@ -3761,7 +3761,7 @@
                   <a:srgbClr val="E5E7EB"/>
                 </a:solidFill>
               </a:rPr>
-              <a:t>6) 그래서 Scanner 선택은 X 방향 Band가 핵심이라고 말합니다.</a:t>
+              <a:t>6) Scanner는 고정되고 기판이 Y로 이동하므로 X Band가 핵심이라고 말합니다.</a:t>
             </a:r>
           </a:p>
           <a:p>
@@ -5327,7 +5327,7 @@
                   <a:srgbClr val="E5E7EB"/>
                 </a:solidFill>
               </a:rPr>
-              <a:t>⑤ Offset / Feedback</a:t>
+              <a:t>⑤ Dynamic Review Correction</a:t>
             </a:r>
           </a:p>
           <a:p>
@@ -5337,7 +5337,7 @@
                   <a:srgbClr val="E5E7EB"/>
                 </a:solidFill>
               </a:rPr>
-              <a:t>• Review 후 X/Y 오차</a:t>
+              <a:t>• 가공 후 Review X/Y 오차</a:t>
             </a:r>
           </a:p>
           <a:p>
@@ -5347,7 +5347,7 @@
                   <a:srgbClr val="E5E7EB"/>
                 </a:solidFill>
               </a:rPr>
-              <a:t>• 다음 가공에 넣을 보정값</a:t>
+              <a:t>• Physical Offset과 분리된 동적 보정값</a:t>
             </a:r>
           </a:p>
           <a:p>

</xml_diff>

<commit_message>
Model reverse-travel MOF process sequence
</commit_message>
<xml_diff>
--- a/downloadable/MOF_COORDINATE_TEAM_LEADER_REPORT_20260717.pptx
+++ b/downloadable/MOF_COORDINATE_TEAM_LEADER_REPORT_20260717.pptx
@@ -1013,7 +1013,7 @@
                   <a:srgbClr val="F8FAFC"/>
                 </a:solidFill>
               </a:rPr>
-              <a:t>11. Step 7 - Dynamic Review Correction으로 다음 가공을 보정한다</a:t>
+              <a:t>11. Step 7 - 역방향 MOF 후 Review Camera에서 측정한다</a:t>
             </a:r>
           </a:p>
         </p:txBody>
@@ -1061,7 +1061,7 @@
                   <a:srgbClr val="E5E7EB"/>
                 </a:solidFill>
               </a:rPr>
-              <a:t>가공한 뒤 Review Camera로 실제 결과를 측정합니다.</a:t>
+              <a:t>역방향 MOF가 끝난 뒤 다음에 만나는 Review Camera에서 실제 가공 결과를 측정합니다.</a:t>
             </a:r>
           </a:p>
           <a:p>
@@ -1923,7 +1923,7 @@
                   <a:srgbClr val="E5E7EB"/>
                 </a:solidFill>
               </a:rPr>
-              <a:t>4) 결과는 Design / Process / Review 좌표로 분리해서 확인합니다.</a:t>
+              <a:t>4) 실행 순서는 Scanner 뒤쪽에서 Review Camera 방향으로 돌아오는 역방향 Y 순서입니다.</a:t>
             </a:r>
           </a:p>
         </p:txBody>
@@ -2587,7 +2587,7 @@
                   <a:srgbClr val="E5E7EB"/>
                 </a:solidFill>
               </a:rPr>
-              <a:t>• 좌표 범위 초과 알람</a:t>
+              <a:t>• Turnaround 위치 및 역방향 MofSequence 검증</a:t>
             </a:r>
           </a:p>
           <a:p>
@@ -2773,7 +2773,7 @@
                   <a:srgbClr val="E5E7EB"/>
                 </a:solidFill>
               </a:rPr>
-              <a:t>• Scanner X Band 판단</a:t>
+              <a:t>• Scanner 뒤쪽 반전 및 역방향 MOF 순서</a:t>
             </a:r>
           </a:p>
           <a:p>
@@ -3751,7 +3751,7 @@
                   <a:srgbClr val="E5E7EB"/>
                 </a:solidFill>
               </a:rPr>
-              <a:t>5) Camera와 Scanner 사이의 고정 물리 Offset을 먼저 설명합니다.</a:t>
+              <a:t>5) Review Camera를 먼저 지나 Scanner 뒤쪽에서 반전한다고 설명합니다.</a:t>
             </a:r>
           </a:p>
           <a:p>
@@ -3761,7 +3761,7 @@
                   <a:srgbClr val="E5E7EB"/>
                 </a:solidFill>
               </a:rPr>
-              <a:t>6) Scanner는 고정되고 기판이 Y로 이동하므로 X Band가 핵심이라고 말합니다.</a:t>
+              <a:t>6) 역방향 복귀 중 MOF를 수행하고 X Band로 담당 Head를 정한다고 말합니다.</a:t>
             </a:r>
           </a:p>
           <a:p>
@@ -3781,7 +3781,7 @@
                   <a:srgbClr val="E5E7EB"/>
                 </a:solidFill>
               </a:rPr>
-              <a:t>8) Review 측정 후 Offset으로 다음 가공을 보정할 수 있다고 마무리합니다.</a:t>
+              <a:t>8) MOF 후 Review Camera에서 측정하고 Home으로 복귀한다고 마무리합니다.</a:t>
             </a:r>
           </a:p>
         </p:txBody>
@@ -6339,7 +6339,7 @@
                   <a:srgbClr val="F8FAFC"/>
                 </a:solidFill>
               </a:rPr>
-              <a:t>8. Step 4 - Scanner는 지그재그로 고정되어 있다</a:t>
+              <a:t>8. Step 4 - Review Camera를 지나 Scanner 뒤쪽에서 반전한다</a:t>
             </a:r>
           </a:p>
         </p:txBody>
@@ -6445,37 +6445,37 @@
                   <a:srgbClr val="E5E7EB"/>
                 </a:solidFill>
               </a:rPr>
-              <a:t>MOF 동작 컨셉</a:t>
-            </a:r>
-          </a:p>
-          <a:p>
-            <a:r>
-              <a:rPr lang="ko-KR" sz="1600">
-                <a:solidFill>
-                  <a:srgbClr val="E5E7EB"/>
-                </a:solidFill>
-              </a:rPr>
-              <a:t>기판이 Scanner 위를 Y 방향으로 지나갑니다.</a:t>
-            </a:r>
-          </a:p>
-          <a:p>
-            <a:r>
-              <a:rPr lang="ko-KR" sz="1600">
-                <a:solidFill>
-                  <a:srgbClr val="E5E7EB"/>
-                </a:solidFill>
-              </a:rPr>
-              <a:t>그래서 Y 방향은 기판 이동으로 커버됩니다.</a:t>
-            </a:r>
-          </a:p>
-          <a:p>
-            <a:r>
-              <a:rPr lang="ko-KR" sz="1600">
-                <a:solidFill>
-                  <a:srgbClr val="E5E7EB"/>
-                </a:solidFill>
-              </a:rPr>
-              <a:t>가공 가능 여부는 X 방향으로 Scanner가 닿는 범위인지가 핵심입니다.</a:t>
+              <a:t>실제 왕복 MOF 동작</a:t>
+            </a:r>
+          </a:p>
+          <a:p>
+            <a:r>
+              <a:rPr lang="ko-KR" sz="1600">
+                <a:solidFill>
+                  <a:srgbClr val="E5E7EB"/>
+                </a:solidFill>
+              </a:rPr>
+              <a:t>기판은 Home에서 Review Camera를 먼저 지나 Scanner 뒤쪽까지 정방향으로 이동합니다.</a:t>
+            </a:r>
+          </a:p>
+          <a:p>
+            <a:r>
+              <a:rPr lang="ko-KR" sz="1600">
+                <a:solidFill>
+                  <a:srgbClr val="E5E7EB"/>
+                </a:solidFill>
+              </a:rPr>
+              <a:t>Scanner 뒤쪽 Turnaround 위치에서 반전한 뒤 역물류 방향으로 돌아옵니다.</a:t>
+            </a:r>
+          </a:p>
+          <a:p>
+            <a:r>
+              <a:rPr lang="ko-KR" sz="1600">
+                <a:solidFill>
+                  <a:srgbClr val="E5E7EB"/>
+                </a:solidFill>
+              </a:rPr>
+              <a:t>역방향 복귀 중 MOF를 수행하며, 가공 가능 여부는 Scanner의 X 커버 범위가 핵심입니다.</a:t>
             </a:r>
           </a:p>
         </p:txBody>

</xml_diff>

<commit_message>
Fix review camera coordinate transform and H1 origin
</commit_message>
<xml_diff>
--- a/downloadable/MOF_COORDINATE_TEAM_LEADER_REPORT_20260717.pptx
+++ b/downloadable/MOF_COORDINATE_TEAM_LEADER_REPORT_20260717.pptx
@@ -523,7 +523,7 @@
                   <a:srgbClr val="E5E7EB"/>
                 </a:solidFill>
               </a:rPr>
-              <a:t>먼저 Camera 기준 상대좌표를 만들고 Head별 Physical Offset을 뺍니다.</a:t>
+              <a:t>G 좌표는 실제 Scanner 중심을 사용하고, Physical Offset 재계산값과 일치하는지 검증합니다.</a:t>
             </a:r>
           </a:p>
         </p:txBody>
@@ -571,17 +571,17 @@
                   <a:srgbClr val="E5E7EB"/>
                 </a:solidFill>
               </a:rPr>
-              <a:t>CameraRelative = ProcessStage - ReviewCenter</a:t>
-            </a:r>
-          </a:p>
-          <a:p>
-            <a:r>
-              <a:rPr lang="ko-KR" sz="1600">
-                <a:solidFill>
-                  <a:srgbClr val="E5E7EB"/>
-                </a:solidFill>
-              </a:rPr>
-              <a:t>ScannerRelative = CameraRelative - CameraToScannerPhysicalOffset</a:t>
+              <a:t>ExpectedH1 = ReviewCenter + H1 PhysicalOffset</a:t>
+            </a:r>
+          </a:p>
+          <a:p>
+            <a:r>
+              <a:rPr lang="ko-KR" sz="1600">
+                <a:solidFill>
+                  <a:srgbClr val="E5E7EB"/>
+                </a:solidFill>
+              </a:rPr>
+              <a:t>ScannerRelative = ProcessStage - ScannerCenter</a:t>
             </a:r>
           </a:p>
           <a:p>
@@ -855,7 +855,7 @@
                   <a:srgbClr val="E5E7EB"/>
                 </a:solidFill>
               </a:rPr>
-              <a:t>BasisHeadDoeStage = 선택 Scanner 중심 + DoeOffset</a:t>
+              <a:t>ScannerRelativeStage = ProcessStage - SelectedHeadCenter</a:t>
             </a:r>
           </a:p>
           <a:p>
@@ -865,7 +865,7 @@
                   <a:srgbClr val="E5E7EB"/>
                 </a:solidFill>
               </a:rPr>
-              <a:t>ReviewCoord = ProcessStage - BasisHeadDoeStage</a:t>
+              <a:t>ReviewCoord = ScannerRelativeStage + PhysicalOffset + DoeStageOffset</a:t>
             </a:r>
           </a:p>
           <a:p>
@@ -885,7 +885,7 @@
                   <a:srgbClr val="E5E7EB"/>
                 </a:solidFill>
               </a:rPr>
-              <a:t>즉, 선택한 DOE Beam을 원점처럼 보고 모든 좌표를 다시 표현합니다.</a:t>
+              <a:t>Scanner 상대 Stage 좌표를 물리 Offset으로 실제 Review Camera 좌표계에 되돌리고 선택 DOE 위치를 더합니다.</a:t>
             </a:r>
           </a:p>
         </p:txBody>
@@ -943,7 +943,7 @@
                   <a:srgbClr val="E5E7EB"/>
                 </a:solidFill>
               </a:rPr>
-              <a:t>선택한 Beam 기준으로 Review 2D Matrix의 모든 좌표가 다시 계산됩니다.</a:t>
+              <a:t>선택한 Beam의 실제 Stage Offset을 반영해 Review Camera 2D Matrix를 다시 계산합니다.</a:t>
             </a:r>
           </a:p>
         </p:txBody>
@@ -1649,7 +1649,7 @@
                   <a:srgbClr val="E5E7EB"/>
                 </a:solidFill>
               </a:rPr>
-              <a:t>Board, Review, Cell, Scanner, DOE, Offset 값이 모두 이 안에 들어갑니다.</a:t>
+              <a:t>Board, Review, Cell, H1 Initial, Physical Offset, Scanner, DOE, Correction 값이 들어갑니다.</a:t>
             </a:r>
           </a:p>
           <a:p>
@@ -1775,7 +1775,7 @@
                   <a:srgbClr val="E5E7EB"/>
                 </a:solidFill>
               </a:rPr>
-              <a:t>각 CellCommand는 한 가공점의 설계 좌표, Stage 좌표, Scanner 번호, Gx/Gy, Review 좌표를 들고 다닙니다.</a:t>
+              <a:t>각 CellCommand는 Scanner 상대좌표, Physical Offset 검증오차, Gx/Gy와 실제 Review Camera 좌표를 들고 다닙니다.</a:t>
             </a:r>
           </a:p>
         </p:txBody>
@@ -2401,7 +2401,7 @@
                   <a:srgbClr val="E5E7EB"/>
                 </a:solidFill>
               </a:rPr>
-              <a:t>• Review Camera→H1 Physical Offset 실측값</a:t>
+              <a:t>• H1 Initial Stage와 Camera→H1 Physical Offset 일치 검증</a:t>
             </a:r>
           </a:p>
           <a:p>
@@ -5151,7 +5151,7 @@
                   <a:srgbClr val="E5E7EB"/>
                 </a:solidFill>
               </a:rPr>
-              <a:t>• 첫 Scanner 중심</a:t>
+              <a:t>• H1 Initial Stage / Physical Offset</a:t>
             </a:r>
           </a:p>
           <a:p>
@@ -5201,7 +5201,7 @@
                   <a:srgbClr val="E5E7EB"/>
                 </a:solidFill>
               </a:rPr>
-              <a:t>헤드가 실제 어디에 고정되어 있는지 나타냅니다.</a:t>
+              <a:t>H1 실제 위치와 ReviewCenter+PhysicalOffset 기대값을 함께 검증합니다.</a:t>
             </a:r>
           </a:p>
         </p:txBody>

</xml_diff>